<commit_message>
Icons changes and some unnecessary change
</commit_message>
<xml_diff>
--- a/uploaded_files/p1.pptx
+++ b/uploaded_files/p1.pptx
@@ -498,7 +498,7 @@
           <a:p>
             <a:fld id="{830FB5D7-9D07-452B-99B7-E2212EAD1E99}" type="datetimeFigureOut">
               <a:rPr lang="en-US" smtClean="0"/>
-              <a:t>9/14/2025</a:t>
+              <a:t>1/3/2026</a:t>
             </a:fld>
             <a:endParaRPr lang="en-US" dirty="0"/>
           </a:p>
@@ -912,7 +912,7 @@
           <a:p>
             <a:fld id="{23004BA8-63A1-45DE-95BC-9B64C824F7E5}" type="datetimeFigureOut">
               <a:rPr lang="en-US" smtClean="0"/>
-              <a:t>9/14/2025</a:t>
+              <a:t>1/3/2026</a:t>
             </a:fld>
             <a:endParaRPr lang="en-US" dirty="0"/>
           </a:p>
@@ -1110,7 +1110,7 @@
           <a:p>
             <a:fld id="{23004BA8-63A1-45DE-95BC-9B64C824F7E5}" type="datetimeFigureOut">
               <a:rPr lang="en-US" smtClean="0"/>
-              <a:t>9/14/2025</a:t>
+              <a:t>1/3/2026</a:t>
             </a:fld>
             <a:endParaRPr lang="en-US" dirty="0"/>
           </a:p>
@@ -1318,7 +1318,7 @@
           <a:p>
             <a:fld id="{23004BA8-63A1-45DE-95BC-9B64C824F7E5}" type="datetimeFigureOut">
               <a:rPr lang="en-US" smtClean="0"/>
-              <a:t>9/14/2025</a:t>
+              <a:t>1/3/2026</a:t>
             </a:fld>
             <a:endParaRPr lang="en-US" dirty="0"/>
           </a:p>
@@ -1516,7 +1516,7 @@
           <a:p>
             <a:fld id="{23004BA8-63A1-45DE-95BC-9B64C824F7E5}" type="datetimeFigureOut">
               <a:rPr lang="en-US" smtClean="0"/>
-              <a:t>9/14/2025</a:t>
+              <a:t>1/3/2026</a:t>
             </a:fld>
             <a:endParaRPr lang="en-US" dirty="0"/>
           </a:p>
@@ -1791,7 +1791,7 @@
           <a:p>
             <a:fld id="{23004BA8-63A1-45DE-95BC-9B64C824F7E5}" type="datetimeFigureOut">
               <a:rPr lang="en-US" smtClean="0"/>
-              <a:t>9/14/2025</a:t>
+              <a:t>1/3/2026</a:t>
             </a:fld>
             <a:endParaRPr lang="en-US" dirty="0"/>
           </a:p>
@@ -2056,7 +2056,7 @@
           <a:p>
             <a:fld id="{23004BA8-63A1-45DE-95BC-9B64C824F7E5}" type="datetimeFigureOut">
               <a:rPr lang="en-US" smtClean="0"/>
-              <a:t>9/14/2025</a:t>
+              <a:t>1/3/2026</a:t>
             </a:fld>
             <a:endParaRPr lang="en-US" dirty="0"/>
           </a:p>
@@ -2468,7 +2468,7 @@
           <a:p>
             <a:fld id="{23004BA8-63A1-45DE-95BC-9B64C824F7E5}" type="datetimeFigureOut">
               <a:rPr lang="en-US" smtClean="0"/>
-              <a:t>9/14/2025</a:t>
+              <a:t>1/3/2026</a:t>
             </a:fld>
             <a:endParaRPr lang="en-US" dirty="0"/>
           </a:p>
@@ -2609,7 +2609,7 @@
           <a:p>
             <a:fld id="{23004BA8-63A1-45DE-95BC-9B64C824F7E5}" type="datetimeFigureOut">
               <a:rPr lang="en-US" smtClean="0"/>
-              <a:t>9/14/2025</a:t>
+              <a:t>1/3/2026</a:t>
             </a:fld>
             <a:endParaRPr lang="en-US" dirty="0"/>
           </a:p>
@@ -2722,7 +2722,7 @@
           <a:p>
             <a:fld id="{23004BA8-63A1-45DE-95BC-9B64C824F7E5}" type="datetimeFigureOut">
               <a:rPr lang="en-US" smtClean="0"/>
-              <a:t>9/14/2025</a:t>
+              <a:t>1/3/2026</a:t>
             </a:fld>
             <a:endParaRPr lang="en-US" dirty="0"/>
           </a:p>
@@ -3033,7 +3033,7 @@
           <a:p>
             <a:fld id="{23004BA8-63A1-45DE-95BC-9B64C824F7E5}" type="datetimeFigureOut">
               <a:rPr lang="en-US" smtClean="0"/>
-              <a:t>9/14/2025</a:t>
+              <a:t>1/3/2026</a:t>
             </a:fld>
             <a:endParaRPr lang="en-US" dirty="0"/>
           </a:p>
@@ -3321,7 +3321,7 @@
           <a:p>
             <a:fld id="{23004BA8-63A1-45DE-95BC-9B64C824F7E5}" type="datetimeFigureOut">
               <a:rPr lang="en-US" smtClean="0"/>
-              <a:t>9/14/2025</a:t>
+              <a:t>1/3/2026</a:t>
             </a:fld>
             <a:endParaRPr lang="en-US" dirty="0"/>
           </a:p>
@@ -3562,7 +3562,7 @@
           <a:p>
             <a:fld id="{23004BA8-63A1-45DE-95BC-9B64C824F7E5}" type="datetimeFigureOut">
               <a:rPr lang="en-US" smtClean="0"/>
-              <a:t>9/14/2025</a:t>
+              <a:t>1/3/2026</a:t>
             </a:fld>
             <a:endParaRPr lang="en-US" dirty="0"/>
           </a:p>
@@ -8050,15 +8050,6 @@
 </file>
 
 <file path=customXml/item1.xml><?xml version="1.0" encoding="utf-8"?>
-<?mso-contentType ?>
-<FormTemplates xmlns="http://schemas.microsoft.com/sharepoint/v3/contenttype/forms">
-  <Display>DocumentLibraryForm</Display>
-  <Edit>DocumentLibraryForm</Edit>
-  <New>DocumentLibraryForm</New>
-</FormTemplates>
-</file>
-
-<file path=customXml/item2.xml><?xml version="1.0" encoding="utf-8"?>
 <p:properties xmlns:p="http://schemas.microsoft.com/office/2006/metadata/properties" xmlns:xsi="http://www.w3.org/2001/XMLSchema-instance" xmlns:pc="http://schemas.microsoft.com/office/infopath/2007/PartnerControls">
   <documentManagement>
     <lcf76f155ced4ddcb4097134ff3c332f xmlns="f7eaa6df-661f-4604-8cff-c91cf36610a5">
@@ -8067,6 +8058,15 @@
     <TaxCatchAll xmlns="5de708c7-6ebf-4b51-a995-ecc64498b673" xsi:nil="true"/>
   </documentManagement>
 </p:properties>
+</file>
+
+<file path=customXml/item2.xml><?xml version="1.0" encoding="utf-8"?>
+<?mso-contentType ?>
+<FormTemplates xmlns="http://schemas.microsoft.com/sharepoint/v3/contenttype/forms">
+  <Display>DocumentLibraryForm</Display>
+  <Edit>DocumentLibraryForm</Edit>
+  <New>DocumentLibraryForm</New>
+</FormTemplates>
 </file>
 
 <file path=customXml/item3.xml><?xml version="1.0" encoding="utf-8"?>
@@ -8319,14 +8319,6 @@
 </file>
 
 <file path=customXml/itemProps1.xml><?xml version="1.0" encoding="utf-8"?>
-<ds:datastoreItem xmlns:ds="http://schemas.openxmlformats.org/officeDocument/2006/customXml" ds:itemID="{6C86FAAA-ED91-448F-91D3-468D9B3AD369}">
-  <ds:schemaRefs>
-    <ds:schemaRef ds:uri="http://schemas.microsoft.com/sharepoint/v3/contenttype/forms"/>
-  </ds:schemaRefs>
-</ds:datastoreItem>
-</file>
-
-<file path=customXml/itemProps2.xml><?xml version="1.0" encoding="utf-8"?>
 <ds:datastoreItem xmlns:ds="http://schemas.openxmlformats.org/officeDocument/2006/customXml" ds:itemID="{95762F25-420A-4863-BE2B-992F6A74EEF2}">
   <ds:schemaRefs>
     <ds:schemaRef ds:uri="http://purl.org/dc/elements/1.1/"/>
@@ -8339,6 +8331,14 @@
     <ds:schemaRef ds:uri="f7eaa6df-661f-4604-8cff-c91cf36610a5"/>
     <ds:schemaRef ds:uri="5de708c7-6ebf-4b51-a995-ecc64498b673"/>
     <ds:schemaRef ds:uri="http://purl.org/dc/dcmitype/"/>
+  </ds:schemaRefs>
+</ds:datastoreItem>
+</file>
+
+<file path=customXml/itemProps2.xml><?xml version="1.0" encoding="utf-8"?>
+<ds:datastoreItem xmlns:ds="http://schemas.openxmlformats.org/officeDocument/2006/customXml" ds:itemID="{6C86FAAA-ED91-448F-91D3-468D9B3AD369}">
+  <ds:schemaRefs>
+    <ds:schemaRef ds:uri="http://schemas.microsoft.com/sharepoint/v3/contenttype/forms"/>
   </ds:schemaRefs>
 </ds:datastoreItem>
 </file>

</xml_diff>